<commit_message>
Add scripts for downloading models and exporting conference papers to CSV
</commit_message>
<xml_diff>
--- a/Docs/Semantic Search Engine for CVPR 2026 Academic Literature.pptx
+++ b/Docs/Semantic Search Engine for CVPR 2026 Academic Literature.pptx
@@ -6,11 +6,11 @@
   </p:sldMasterIdLst>
   <p:sldIdLst>
     <p:sldId id="256" r:id="rId2"/>
-    <p:sldId id="258" r:id="rId3"/>
+    <p:sldId id="262" r:id="rId3"/>
     <p:sldId id="260" r:id="rId4"/>
-    <p:sldId id="257" r:id="rId5"/>
-    <p:sldId id="261" r:id="rId6"/>
-    <p:sldId id="259" r:id="rId7"/>
+    <p:sldId id="258" r:id="rId5"/>
+    <p:sldId id="257" r:id="rId6"/>
+    <p:sldId id="263" r:id="rId7"/>
   </p:sldIdLst>
   <p:sldSz cx="12192000" cy="6858000"/>
   <p:notesSz cx="6858000" cy="9144000"/>
@@ -266,7 +266,7 @@
           <a:p>
             <a:fld id="{756BEFB0-C86D-4E60-A5F1-3C6A4FC28D6B}" type="datetimeFigureOut">
               <a:rPr lang="en-IL" smtClean="0"/>
-              <a:t>23/06/2026</a:t>
+              <a:t>25/07/2026</a:t>
             </a:fld>
             <a:endParaRPr lang="en-IL"/>
           </a:p>
@@ -466,7 +466,7 @@
           <a:p>
             <a:fld id="{756BEFB0-C86D-4E60-A5F1-3C6A4FC28D6B}" type="datetimeFigureOut">
               <a:rPr lang="en-IL" smtClean="0"/>
-              <a:t>23/06/2026</a:t>
+              <a:t>25/07/2026</a:t>
             </a:fld>
             <a:endParaRPr lang="en-IL"/>
           </a:p>
@@ -676,7 +676,7 @@
           <a:p>
             <a:fld id="{756BEFB0-C86D-4E60-A5F1-3C6A4FC28D6B}" type="datetimeFigureOut">
               <a:rPr lang="en-IL" smtClean="0"/>
-              <a:t>23/06/2026</a:t>
+              <a:t>25/07/2026</a:t>
             </a:fld>
             <a:endParaRPr lang="en-IL"/>
           </a:p>
@@ -876,7 +876,7 @@
           <a:p>
             <a:fld id="{756BEFB0-C86D-4E60-A5F1-3C6A4FC28D6B}" type="datetimeFigureOut">
               <a:rPr lang="en-IL" smtClean="0"/>
-              <a:t>23/06/2026</a:t>
+              <a:t>25/07/2026</a:t>
             </a:fld>
             <a:endParaRPr lang="en-IL"/>
           </a:p>
@@ -1152,7 +1152,7 @@
           <a:p>
             <a:fld id="{756BEFB0-C86D-4E60-A5F1-3C6A4FC28D6B}" type="datetimeFigureOut">
               <a:rPr lang="en-IL" smtClean="0"/>
-              <a:t>23/06/2026</a:t>
+              <a:t>25/07/2026</a:t>
             </a:fld>
             <a:endParaRPr lang="en-IL"/>
           </a:p>
@@ -1420,7 +1420,7 @@
           <a:p>
             <a:fld id="{756BEFB0-C86D-4E60-A5F1-3C6A4FC28D6B}" type="datetimeFigureOut">
               <a:rPr lang="en-IL" smtClean="0"/>
-              <a:t>23/06/2026</a:t>
+              <a:t>25/07/2026</a:t>
             </a:fld>
             <a:endParaRPr lang="en-IL"/>
           </a:p>
@@ -1835,7 +1835,7 @@
           <a:p>
             <a:fld id="{756BEFB0-C86D-4E60-A5F1-3C6A4FC28D6B}" type="datetimeFigureOut">
               <a:rPr lang="en-IL" smtClean="0"/>
-              <a:t>23/06/2026</a:t>
+              <a:t>25/07/2026</a:t>
             </a:fld>
             <a:endParaRPr lang="en-IL"/>
           </a:p>
@@ -1977,7 +1977,7 @@
           <a:p>
             <a:fld id="{756BEFB0-C86D-4E60-A5F1-3C6A4FC28D6B}" type="datetimeFigureOut">
               <a:rPr lang="en-IL" smtClean="0"/>
-              <a:t>23/06/2026</a:t>
+              <a:t>25/07/2026</a:t>
             </a:fld>
             <a:endParaRPr lang="en-IL"/>
           </a:p>
@@ -2090,7 +2090,7 @@
           <a:p>
             <a:fld id="{756BEFB0-C86D-4E60-A5F1-3C6A4FC28D6B}" type="datetimeFigureOut">
               <a:rPr lang="en-IL" smtClean="0"/>
-              <a:t>23/06/2026</a:t>
+              <a:t>25/07/2026</a:t>
             </a:fld>
             <a:endParaRPr lang="en-IL"/>
           </a:p>
@@ -2403,7 +2403,7 @@
           <a:p>
             <a:fld id="{756BEFB0-C86D-4E60-A5F1-3C6A4FC28D6B}" type="datetimeFigureOut">
               <a:rPr lang="en-IL" smtClean="0"/>
-              <a:t>23/06/2026</a:t>
+              <a:t>25/07/2026</a:t>
             </a:fld>
             <a:endParaRPr lang="en-IL"/>
           </a:p>
@@ -2692,7 +2692,7 @@
           <a:p>
             <a:fld id="{756BEFB0-C86D-4E60-A5F1-3C6A4FC28D6B}" type="datetimeFigureOut">
               <a:rPr lang="en-IL" smtClean="0"/>
-              <a:t>23/06/2026</a:t>
+              <a:t>25/07/2026</a:t>
             </a:fld>
             <a:endParaRPr lang="en-IL"/>
           </a:p>
@@ -2770,36 +2770,12 @@
   <p:cSld>
     <p:bg>
       <p:bgPr>
-        <a:gradFill flip="none" rotWithShape="1">
-          <a:gsLst>
-            <a:gs pos="0">
-              <a:schemeClr val="accent1">
-                <a:lumMod val="8000"/>
-                <a:lumOff val="92000"/>
-              </a:schemeClr>
-            </a:gs>
-            <a:gs pos="74000">
-              <a:schemeClr val="accent1">
-                <a:lumMod val="45000"/>
-                <a:lumOff val="55000"/>
-              </a:schemeClr>
-            </a:gs>
-            <a:gs pos="83000">
-              <a:schemeClr val="accent1">
-                <a:lumMod val="45000"/>
-                <a:lumOff val="55000"/>
-              </a:schemeClr>
-            </a:gs>
-            <a:gs pos="100000">
-              <a:schemeClr val="accent1">
-                <a:lumMod val="30000"/>
-                <a:lumOff val="70000"/>
-              </a:schemeClr>
-            </a:gs>
-          </a:gsLst>
-          <a:lin ang="5400000" scaled="1"/>
-          <a:tileRect/>
-        </a:gradFill>
+        <a:solidFill>
+          <a:schemeClr val="tx1">
+            <a:lumMod val="50000"/>
+            <a:lumOff val="50000"/>
+          </a:schemeClr>
+        </a:solidFill>
         <a:effectLst/>
       </p:bgPr>
     </p:bg>
@@ -2965,7 +2941,7 @@
           <a:p>
             <a:fld id="{756BEFB0-C86D-4E60-A5F1-3C6A4FC28D6B}" type="datetimeFigureOut">
               <a:rPr lang="en-IL" smtClean="0"/>
-              <a:t>23/06/2026</a:t>
+              <a:t>25/07/2026</a:t>
             </a:fld>
             <a:endParaRPr lang="en-IL"/>
           </a:p>
@@ -3473,7 +3449,7 @@
           <p:cNvPr id="2" name="Title 1">
             <a:extLst>
               <a:ext uri="{FF2B5EF4-FFF2-40B4-BE49-F238E27FC236}">
-                <a16:creationId xmlns:a16="http://schemas.microsoft.com/office/drawing/2014/main" id="{2684DA81-633D-F68B-50DB-2A705811D451}"/>
+                <a16:creationId xmlns:a16="http://schemas.microsoft.com/office/drawing/2014/main" id="{1292F2F6-2CD3-07ED-4FB1-6C7948D4AC07}"/>
               </a:ext>
             </a:extLst>
           </p:cNvPr>
@@ -3486,7 +3462,866 @@
         </p:nvSpPr>
         <p:spPr>
           <a:xfrm>
-            <a:off x="561000" y="234000"/>
+            <a:off x="471000" y="234000"/>
+            <a:ext cx="10515600" cy="1325563"/>
+          </a:xfrm>
+        </p:spPr>
+        <p:txBody>
+          <a:bodyPr vert="horz" lIns="91440" tIns="45720" rIns="91440" bIns="45720" rtlCol="0" anchor="ctr">
+            <a:normAutofit/>
+          </a:bodyPr>
+          <a:lstStyle/>
+          <a:p>
+            <a:r>
+              <a:rPr lang="he-IL" dirty="0" err="1"/>
+              <a:t>Project</a:t>
+            </a:r>
+            <a:r>
+              <a:rPr lang="he-IL" dirty="0"/>
+              <a:t> </a:t>
+            </a:r>
+            <a:r>
+              <a:rPr lang="he-IL" dirty="0" err="1"/>
+              <a:t>Goals</a:t>
+            </a:r>
+            <a:r>
+              <a:rPr lang="en-US" dirty="0"/>
+              <a:t>:</a:t>
+            </a:r>
+            <a:endParaRPr lang="he-IL" dirty="0"/>
+          </a:p>
+        </p:txBody>
+      </p:sp>
+      <p:sp>
+        <p:nvSpPr>
+          <p:cNvPr id="3" name="Content Placeholder 2">
+            <a:extLst>
+              <a:ext uri="{FF2B5EF4-FFF2-40B4-BE49-F238E27FC236}">
+                <a16:creationId xmlns:a16="http://schemas.microsoft.com/office/drawing/2014/main" id="{1DFB5F78-5A89-3C99-FE8D-963A76B9A3E1}"/>
+              </a:ext>
+            </a:extLst>
+          </p:cNvPr>
+          <p:cNvSpPr>
+            <a:spLocks noGrp="1"/>
+          </p:cNvSpPr>
+          <p:nvPr>
+            <p:ph idx="1"/>
+          </p:nvPr>
+        </p:nvSpPr>
+        <p:spPr/>
+        <p:txBody>
+          <a:bodyPr>
+            <a:normAutofit lnSpcReduction="10000"/>
+          </a:bodyPr>
+          <a:lstStyle/>
+          <a:p>
+            <a:pPr marL="0" indent="0">
+              <a:buNone/>
+            </a:pPr>
+            <a:r>
+              <a:rPr lang="he-IL" b="1" u="sng" dirty="0" err="1"/>
+              <a:t>Bridge</a:t>
+            </a:r>
+            <a:r>
+              <a:rPr lang="he-IL" b="1" u="sng" dirty="0"/>
+              <a:t> </a:t>
+            </a:r>
+            <a:r>
+              <a:rPr lang="he-IL" b="1" u="sng" dirty="0" err="1"/>
+              <a:t>the</a:t>
+            </a:r>
+            <a:r>
+              <a:rPr lang="he-IL" b="1" u="sng" dirty="0"/>
+              <a:t> </a:t>
+            </a:r>
+            <a:r>
+              <a:rPr lang="he-IL" b="1" u="sng" dirty="0" err="1"/>
+              <a:t>Information</a:t>
+            </a:r>
+            <a:r>
+              <a:rPr lang="he-IL" b="1" u="sng" dirty="0"/>
+              <a:t> </a:t>
+            </a:r>
+            <a:r>
+              <a:rPr lang="he-IL" b="1" u="sng" dirty="0" err="1"/>
+              <a:t>Gap</a:t>
+            </a:r>
+            <a:endParaRPr lang="he-IL" b="1" u="sng" dirty="0"/>
+          </a:p>
+          <a:p>
+            <a:r>
+              <a:rPr lang="he-IL" dirty="0" err="1"/>
+              <a:t>Make</a:t>
+            </a:r>
+            <a:r>
+              <a:rPr lang="he-IL" dirty="0"/>
+              <a:t> </a:t>
+            </a:r>
+            <a:r>
+              <a:rPr lang="he-IL" dirty="0" err="1"/>
+              <a:t>the</a:t>
+            </a:r>
+            <a:r>
+              <a:rPr lang="he-IL" dirty="0"/>
+              <a:t> </a:t>
+            </a:r>
+            <a:r>
+              <a:rPr lang="he-IL" dirty="0" err="1"/>
+              <a:t>published</a:t>
+            </a:r>
+            <a:r>
+              <a:rPr lang="he-IL" dirty="0"/>
+              <a:t> </a:t>
+            </a:r>
+            <a:r>
+              <a:rPr lang="he-IL" dirty="0" err="1"/>
+              <a:t>conference</a:t>
+            </a:r>
+            <a:r>
+              <a:rPr lang="he-IL" dirty="0"/>
+              <a:t> </a:t>
+            </a:r>
+            <a:r>
+              <a:rPr lang="he-IL" dirty="0" err="1"/>
+              <a:t>data</a:t>
+            </a:r>
+            <a:r>
+              <a:rPr lang="he-IL" dirty="0"/>
+              <a:t> </a:t>
+            </a:r>
+            <a:r>
+              <a:rPr lang="he-IL" dirty="0" err="1"/>
+              <a:t>readily</a:t>
+            </a:r>
+            <a:r>
+              <a:rPr lang="he-IL" dirty="0"/>
+              <a:t> </a:t>
+            </a:r>
+            <a:r>
+              <a:rPr lang="he-IL" dirty="0" err="1"/>
+              <a:t>accessible</a:t>
+            </a:r>
+            <a:r>
+              <a:rPr lang="he-IL" dirty="0"/>
+              <a:t> </a:t>
+            </a:r>
+            <a:r>
+              <a:rPr lang="he-IL" dirty="0" err="1"/>
+              <a:t>and</a:t>
+            </a:r>
+            <a:r>
+              <a:rPr lang="he-IL" dirty="0"/>
+              <a:t> </a:t>
+            </a:r>
+            <a:r>
+              <a:rPr lang="he-IL" dirty="0" err="1"/>
+              <a:t>actionable</a:t>
+            </a:r>
+            <a:r>
+              <a:rPr lang="he-IL" dirty="0"/>
+              <a:t> </a:t>
+            </a:r>
+            <a:r>
+              <a:rPr lang="he-IL" dirty="0" err="1"/>
+              <a:t>for</a:t>
+            </a:r>
+            <a:r>
+              <a:rPr lang="he-IL" dirty="0"/>
+              <a:t> </a:t>
+            </a:r>
+            <a:r>
+              <a:rPr lang="he-IL" dirty="0" err="1"/>
+              <a:t>the</a:t>
+            </a:r>
+            <a:r>
+              <a:rPr lang="he-IL" dirty="0"/>
+              <a:t> </a:t>
+            </a:r>
+            <a:r>
+              <a:rPr lang="he-IL" b="1" dirty="0" err="1"/>
+              <a:t>Spaik</a:t>
+            </a:r>
+            <a:r>
+              <a:rPr lang="he-IL" dirty="0"/>
+              <a:t> </a:t>
+            </a:r>
+            <a:r>
+              <a:rPr lang="he-IL" dirty="0" err="1"/>
+              <a:t>community</a:t>
+            </a:r>
+            <a:r>
+              <a:rPr lang="he-IL" dirty="0"/>
+              <a:t>.</a:t>
+            </a:r>
+          </a:p>
+          <a:p>
+            <a:pPr marL="0" indent="0">
+              <a:buNone/>
+            </a:pPr>
+            <a:r>
+              <a:rPr lang="he-IL" b="1" u="sng" dirty="0" err="1"/>
+              <a:t>Tailored</a:t>
+            </a:r>
+            <a:r>
+              <a:rPr lang="he-IL" b="1" u="sng" dirty="0"/>
+              <a:t> </a:t>
+            </a:r>
+            <a:r>
+              <a:rPr lang="he-IL" b="1" u="sng" dirty="0" err="1"/>
+              <a:t>Search</a:t>
+            </a:r>
+            <a:r>
+              <a:rPr lang="he-IL" b="1" u="sng" dirty="0"/>
+              <a:t> </a:t>
+            </a:r>
+            <a:r>
+              <a:rPr lang="he-IL" b="1" u="sng" dirty="0" err="1"/>
+              <a:t>Methodology</a:t>
+            </a:r>
+            <a:endParaRPr lang="he-IL" b="1" u="sng" dirty="0"/>
+          </a:p>
+          <a:p>
+            <a:r>
+              <a:rPr lang="he-IL" dirty="0" err="1"/>
+              <a:t>Adapt</a:t>
+            </a:r>
+            <a:r>
+              <a:rPr lang="he-IL" dirty="0"/>
+              <a:t> </a:t>
+            </a:r>
+            <a:r>
+              <a:rPr lang="he-IL" dirty="0" err="1"/>
+              <a:t>an</a:t>
+            </a:r>
+            <a:r>
+              <a:rPr lang="he-IL" dirty="0"/>
+              <a:t> </a:t>
+            </a:r>
+            <a:r>
+              <a:rPr lang="he-IL" dirty="0" err="1"/>
+              <a:t>efficient</a:t>
+            </a:r>
+            <a:r>
+              <a:rPr lang="he-IL" dirty="0"/>
+              <a:t> </a:t>
+            </a:r>
+            <a:r>
+              <a:rPr lang="he-IL" dirty="0" err="1"/>
+              <a:t>search</a:t>
+            </a:r>
+            <a:r>
+              <a:rPr lang="he-IL" dirty="0"/>
+              <a:t> </a:t>
+            </a:r>
+            <a:r>
+              <a:rPr lang="he-IL" dirty="0" err="1"/>
+              <a:t>and</a:t>
+            </a:r>
+            <a:r>
+              <a:rPr lang="he-IL" dirty="0"/>
+              <a:t> </a:t>
+            </a:r>
+            <a:r>
+              <a:rPr lang="he-IL" dirty="0" err="1"/>
+              <a:t>retrieval</a:t>
+            </a:r>
+            <a:r>
+              <a:rPr lang="he-IL" dirty="0"/>
+              <a:t> </a:t>
+            </a:r>
+            <a:r>
+              <a:rPr lang="he-IL" dirty="0" err="1"/>
+              <a:t>methodology</a:t>
+            </a:r>
+            <a:r>
+              <a:rPr lang="he-IL" dirty="0"/>
+              <a:t> </a:t>
+            </a:r>
+            <a:r>
+              <a:rPr lang="he-IL" dirty="0" err="1"/>
+              <a:t>customized</a:t>
+            </a:r>
+            <a:r>
+              <a:rPr lang="he-IL" dirty="0"/>
+              <a:t> </a:t>
+            </a:r>
+            <a:r>
+              <a:rPr lang="he-IL" dirty="0" err="1"/>
+              <a:t>to</a:t>
+            </a:r>
+            <a:r>
+              <a:rPr lang="he-IL" dirty="0"/>
+              <a:t> </a:t>
+            </a:r>
+            <a:r>
+              <a:rPr lang="he-IL" dirty="0" err="1"/>
+              <a:t>the</a:t>
+            </a:r>
+            <a:r>
+              <a:rPr lang="he-IL" dirty="0"/>
+              <a:t> </a:t>
+            </a:r>
+            <a:r>
+              <a:rPr lang="he-IL" dirty="0" err="1"/>
+              <a:t>specific</a:t>
+            </a:r>
+            <a:r>
+              <a:rPr lang="he-IL" dirty="0"/>
+              <a:t> </a:t>
+            </a:r>
+            <a:r>
+              <a:rPr lang="he-IL" dirty="0" err="1"/>
+              <a:t>scientific</a:t>
+            </a:r>
+            <a:r>
+              <a:rPr lang="he-IL" dirty="0"/>
+              <a:t> </a:t>
+            </a:r>
+            <a:r>
+              <a:rPr lang="he-IL" dirty="0" err="1"/>
+              <a:t>domains</a:t>
+            </a:r>
+            <a:r>
+              <a:rPr lang="he-IL" dirty="0"/>
+              <a:t> </a:t>
+            </a:r>
+            <a:r>
+              <a:rPr lang="he-IL" dirty="0" err="1"/>
+              <a:t>of</a:t>
+            </a:r>
+            <a:r>
+              <a:rPr lang="he-IL" dirty="0"/>
+              <a:t> </a:t>
+            </a:r>
+            <a:r>
+              <a:rPr lang="he-IL" dirty="0" err="1"/>
+              <a:t>interest</a:t>
+            </a:r>
+            <a:r>
+              <a:rPr lang="he-IL" dirty="0"/>
+              <a:t> </a:t>
+            </a:r>
+            <a:r>
+              <a:rPr lang="he-IL" dirty="0" err="1"/>
+              <a:t>to</a:t>
+            </a:r>
+            <a:r>
+              <a:rPr lang="he-IL" dirty="0"/>
+              <a:t> </a:t>
+            </a:r>
+            <a:r>
+              <a:rPr lang="he-IL" dirty="0" err="1"/>
+              <a:t>our</a:t>
+            </a:r>
+            <a:r>
+              <a:rPr lang="he-IL" dirty="0"/>
+              <a:t> </a:t>
+            </a:r>
+            <a:r>
+              <a:rPr lang="he-IL" dirty="0" err="1"/>
+              <a:t>community</a:t>
+            </a:r>
+            <a:r>
+              <a:rPr lang="he-IL" dirty="0"/>
+              <a:t>.</a:t>
+            </a:r>
+          </a:p>
+          <a:p>
+            <a:pPr marL="0" indent="0">
+              <a:buNone/>
+            </a:pPr>
+            <a:r>
+              <a:rPr lang="he-IL" b="1" dirty="0" err="1"/>
+              <a:t>Strategic</a:t>
+            </a:r>
+            <a:r>
+              <a:rPr lang="he-IL" b="1" dirty="0"/>
+              <a:t> </a:t>
+            </a:r>
+            <a:r>
+              <a:rPr lang="he-IL" b="1" dirty="0" err="1"/>
+              <a:t>Alignment</a:t>
+            </a:r>
+            <a:endParaRPr lang="he-IL" b="1" dirty="0"/>
+          </a:p>
+          <a:p>
+            <a:r>
+              <a:rPr lang="he-IL" dirty="0" err="1"/>
+              <a:t>Equip</a:t>
+            </a:r>
+            <a:r>
+              <a:rPr lang="he-IL" dirty="0"/>
+              <a:t> </a:t>
+            </a:r>
+            <a:r>
+              <a:rPr lang="he-IL" dirty="0" err="1"/>
+              <a:t>and</a:t>
+            </a:r>
+            <a:r>
+              <a:rPr lang="he-IL" dirty="0"/>
+              <a:t> </a:t>
+            </a:r>
+            <a:r>
+              <a:rPr lang="he-IL" dirty="0" err="1"/>
+              <a:t>focus</a:t>
+            </a:r>
+            <a:r>
+              <a:rPr lang="he-IL" dirty="0"/>
+              <a:t> </a:t>
+            </a:r>
+            <a:r>
+              <a:rPr lang="he-IL" dirty="0" err="1"/>
+              <a:t>our</a:t>
+            </a:r>
+            <a:r>
+              <a:rPr lang="he-IL" dirty="0"/>
+              <a:t> </a:t>
+            </a:r>
+            <a:r>
+              <a:rPr lang="he-IL" dirty="0" err="1"/>
+              <a:t>representatives</a:t>
+            </a:r>
+            <a:r>
+              <a:rPr lang="he-IL" dirty="0"/>
+              <a:t> </a:t>
+            </a:r>
+            <a:r>
+              <a:rPr lang="he-IL" dirty="0" err="1"/>
+              <a:t>ahead</a:t>
+            </a:r>
+            <a:r>
+              <a:rPr lang="he-IL" dirty="0"/>
+              <a:t> </a:t>
+            </a:r>
+            <a:r>
+              <a:rPr lang="he-IL" dirty="0" err="1"/>
+              <a:t>of</a:t>
+            </a:r>
+            <a:r>
+              <a:rPr lang="he-IL" dirty="0"/>
+              <a:t> </a:t>
+            </a:r>
+            <a:r>
+              <a:rPr lang="he-IL" dirty="0" err="1"/>
+              <a:t>the</a:t>
+            </a:r>
+            <a:r>
+              <a:rPr lang="he-IL" dirty="0"/>
+              <a:t> </a:t>
+            </a:r>
+            <a:r>
+              <a:rPr lang="he-IL" dirty="0" err="1"/>
+              <a:t>next</a:t>
+            </a:r>
+            <a:r>
+              <a:rPr lang="he-IL" dirty="0"/>
+              <a:t> </a:t>
+            </a:r>
+            <a:r>
+              <a:rPr lang="he-IL" dirty="0" err="1"/>
+              <a:t>conference</a:t>
+            </a:r>
+            <a:r>
+              <a:rPr lang="he-IL" dirty="0"/>
+              <a:t>, </a:t>
+            </a:r>
+            <a:r>
+              <a:rPr lang="he-IL" dirty="0" err="1"/>
+              <a:t>ensuring</a:t>
+            </a:r>
+            <a:r>
+              <a:rPr lang="he-IL" dirty="0"/>
+              <a:t> </a:t>
+            </a:r>
+            <a:r>
+              <a:rPr lang="he-IL" dirty="0" err="1"/>
+              <a:t>targeted</a:t>
+            </a:r>
+            <a:r>
+              <a:rPr lang="he-IL" dirty="0"/>
+              <a:t> </a:t>
+            </a:r>
+            <a:r>
+              <a:rPr lang="he-IL" dirty="0" err="1"/>
+              <a:t>attendance</a:t>
+            </a:r>
+            <a:r>
+              <a:rPr lang="he-IL" dirty="0"/>
+              <a:t> </a:t>
+            </a:r>
+            <a:r>
+              <a:rPr lang="he-IL" dirty="0" err="1"/>
+              <a:t>and</a:t>
+            </a:r>
+            <a:r>
+              <a:rPr lang="he-IL" dirty="0"/>
+              <a:t> </a:t>
+            </a:r>
+            <a:r>
+              <a:rPr lang="he-IL" dirty="0" err="1"/>
+              <a:t>maximum</a:t>
+            </a:r>
+            <a:r>
+              <a:rPr lang="he-IL" dirty="0"/>
+              <a:t> </a:t>
+            </a:r>
+            <a:r>
+              <a:rPr lang="he-IL" dirty="0" err="1"/>
+              <a:t>return</a:t>
+            </a:r>
+            <a:r>
+              <a:rPr lang="he-IL" dirty="0"/>
+              <a:t> </a:t>
+            </a:r>
+            <a:r>
+              <a:rPr lang="he-IL" dirty="0" err="1"/>
+              <a:t>on</a:t>
+            </a:r>
+            <a:r>
+              <a:rPr lang="he-IL" dirty="0"/>
+              <a:t> </a:t>
+            </a:r>
+            <a:r>
+              <a:rPr lang="he-IL" dirty="0" err="1"/>
+              <a:t>participation</a:t>
+            </a:r>
+            <a:r>
+              <a:rPr lang="he-IL" dirty="0"/>
+              <a:t>.</a:t>
+            </a:r>
+          </a:p>
+          <a:p>
+            <a:endParaRPr lang="he-IL" dirty="0"/>
+          </a:p>
+        </p:txBody>
+      </p:sp>
+    </p:spTree>
+    <p:extLst>
+      <p:ext uri="{BB962C8B-B14F-4D97-AF65-F5344CB8AC3E}">
+        <p14:creationId xmlns:p14="http://schemas.microsoft.com/office/powerpoint/2010/main" val="814938447"/>
+      </p:ext>
+    </p:extLst>
+  </p:cSld>
+  <p:clrMapOvr>
+    <a:masterClrMapping/>
+  </p:clrMapOvr>
+</p:sld>
+</file>
+
+<file path=ppt/slides/slide3.xml><?xml version="1.0" encoding="utf-8"?>
+<p:sld xmlns:a="http://schemas.openxmlformats.org/drawingml/2006/main" xmlns:r="http://schemas.openxmlformats.org/officeDocument/2006/relationships" xmlns:p="http://schemas.openxmlformats.org/presentationml/2006/main">
+  <p:cSld>
+    <p:spTree>
+      <p:nvGrpSpPr>
+        <p:cNvPr id="1" name=""/>
+        <p:cNvGrpSpPr/>
+        <p:nvPr/>
+      </p:nvGrpSpPr>
+      <p:grpSpPr>
+        <a:xfrm>
+          <a:off x="0" y="0"/>
+          <a:ext cx="0" cy="0"/>
+          <a:chOff x="0" y="0"/>
+          <a:chExt cx="0" cy="0"/>
+        </a:xfrm>
+      </p:grpSpPr>
+      <p:sp>
+        <p:nvSpPr>
+          <p:cNvPr id="2" name="Title 1">
+            <a:extLst>
+              <a:ext uri="{FF2B5EF4-FFF2-40B4-BE49-F238E27FC236}">
+                <a16:creationId xmlns:a16="http://schemas.microsoft.com/office/drawing/2014/main" id="{79613971-1F6C-5EB3-FF31-0D694CE6D0DE}"/>
+              </a:ext>
+            </a:extLst>
+          </p:cNvPr>
+          <p:cNvSpPr>
+            <a:spLocks noGrp="1"/>
+          </p:cNvSpPr>
+          <p:nvPr>
+            <p:ph type="title"/>
+          </p:nvPr>
+        </p:nvSpPr>
+        <p:spPr>
+          <a:xfrm>
+            <a:off x="9912" y="0"/>
+            <a:ext cx="10515600" cy="954000"/>
+          </a:xfrm>
+        </p:spPr>
+        <p:txBody>
+          <a:bodyPr>
+            <a:normAutofit/>
+          </a:bodyPr>
+          <a:lstStyle/>
+          <a:p>
+            <a:r>
+              <a:rPr lang="en-US" dirty="0"/>
+              <a:t>Project stages</a:t>
+            </a:r>
+            <a:endParaRPr lang="en-IL" dirty="0"/>
+          </a:p>
+        </p:txBody>
+      </p:sp>
+      <p:sp>
+        <p:nvSpPr>
+          <p:cNvPr id="3" name="Content Placeholder 2">
+            <a:extLst>
+              <a:ext uri="{FF2B5EF4-FFF2-40B4-BE49-F238E27FC236}">
+                <a16:creationId xmlns:a16="http://schemas.microsoft.com/office/drawing/2014/main" id="{27D38D13-1436-D0D0-544F-2CCB6EEFAF00}"/>
+              </a:ext>
+            </a:extLst>
+          </p:cNvPr>
+          <p:cNvSpPr>
+            <a:spLocks noGrp="1"/>
+          </p:cNvSpPr>
+          <p:nvPr>
+            <p:ph idx="1"/>
+          </p:nvPr>
+        </p:nvSpPr>
+        <p:spPr>
+          <a:xfrm>
+            <a:off x="156000" y="819000"/>
+            <a:ext cx="8055000" cy="5984999"/>
+          </a:xfrm>
+        </p:spPr>
+        <p:txBody>
+          <a:bodyPr>
+            <a:normAutofit/>
+          </a:bodyPr>
+          <a:lstStyle/>
+          <a:p>
+            <a:r>
+              <a:rPr lang="en-US" sz="2000" b="1" dirty="0"/>
+              <a:t>Download</a:t>
+            </a:r>
+            <a:r>
+              <a:rPr lang="en-US" sz="2000" dirty="0"/>
+              <a:t>: Created a Python script to download 4,072 PDFs along with their HTML abstracts.</a:t>
+            </a:r>
+          </a:p>
+          <a:p>
+            <a:r>
+              <a:rPr lang="en-US" sz="2000" b="1" dirty="0"/>
+              <a:t>Database Class</a:t>
+            </a:r>
+            <a:r>
+              <a:rPr lang="en-US" sz="2000" dirty="0"/>
+              <a:t>: Developed a Python class to fetch the title, PDF path, and abstract based on a given index.</a:t>
+            </a:r>
+          </a:p>
+          <a:p>
+            <a:r>
+              <a:rPr lang="en-US" sz="2000" b="1" dirty="0"/>
+              <a:t>Model Loading</a:t>
+            </a:r>
+            <a:r>
+              <a:rPr lang="en-US" sz="2000" dirty="0"/>
+              <a:t>: Downloaded and loaded the pretrained BAAI/bge-large-en-v1.5 model.</a:t>
+            </a:r>
+          </a:p>
+          <a:p>
+            <a:r>
+              <a:rPr lang="en-US" sz="2000" b="1" dirty="0"/>
+              <a:t>Semantic Matrix</a:t>
+            </a:r>
+            <a:r>
+              <a:rPr lang="en-US" sz="2000" dirty="0"/>
+              <a:t>: Generated the semantic matrix utilizing the neural network.</a:t>
+            </a:r>
+          </a:p>
+          <a:p>
+            <a:r>
+              <a:rPr lang="en-US" sz="2000" b="1" dirty="0"/>
+              <a:t>Search Function</a:t>
+            </a:r>
+            <a:r>
+              <a:rPr lang="en-US" sz="2000" dirty="0"/>
+              <a:t>: Wrote a Python function that executes the search and returns the top 20 result indexes, sorted by relevance.</a:t>
+            </a:r>
+          </a:p>
+          <a:p>
+            <a:r>
+              <a:rPr lang="en-US" sz="2000" b="1" dirty="0"/>
+              <a:t>Web Interface</a:t>
+            </a:r>
+            <a:r>
+              <a:rPr lang="en-US" sz="2000" dirty="0"/>
+              <a:t>: Developed a website to provide accessible search capabilities and document viewing.</a:t>
+            </a:r>
+          </a:p>
+          <a:p>
+            <a:endParaRPr lang="en-IL" sz="2000" dirty="0"/>
+          </a:p>
+        </p:txBody>
+      </p:sp>
+      <p:pic>
+        <p:nvPicPr>
+          <p:cNvPr id="5" name="Picture 4">
+            <a:extLst>
+              <a:ext uri="{FF2B5EF4-FFF2-40B4-BE49-F238E27FC236}">
+                <a16:creationId xmlns:a16="http://schemas.microsoft.com/office/drawing/2014/main" id="{1ED6AF4C-B716-71E1-5776-F2B20C6BC744}"/>
+              </a:ext>
+            </a:extLst>
+          </p:cNvPr>
+          <p:cNvPicPr>
+            <a:picLocks noChangeAspect="1"/>
+          </p:cNvPicPr>
+          <p:nvPr/>
+        </p:nvPicPr>
+        <p:blipFill>
+          <a:blip r:embed="rId2"/>
+          <a:stretch>
+            <a:fillRect/>
+          </a:stretch>
+        </p:blipFill>
+        <p:spPr>
+          <a:xfrm>
+            <a:off x="8428008" y="729001"/>
+            <a:ext cx="3608688" cy="3015000"/>
+          </a:xfrm>
+          <a:prstGeom prst="rect">
+            <a:avLst/>
+          </a:prstGeom>
+        </p:spPr>
+      </p:pic>
+      <p:sp>
+        <p:nvSpPr>
+          <p:cNvPr id="13" name="Arrow: Curved Right 12">
+            <a:extLst>
+              <a:ext uri="{FF2B5EF4-FFF2-40B4-BE49-F238E27FC236}">
+                <a16:creationId xmlns:a16="http://schemas.microsoft.com/office/drawing/2014/main" id="{7FE069B4-A783-B9F2-AF8B-61F94E6669A6}"/>
+              </a:ext>
+            </a:extLst>
+          </p:cNvPr>
+          <p:cNvSpPr/>
+          <p:nvPr/>
+        </p:nvSpPr>
+        <p:spPr>
+          <a:xfrm>
+            <a:off x="8076000" y="2650501"/>
+            <a:ext cx="351313" cy="2803499"/>
+          </a:xfrm>
+          <a:prstGeom prst="curvedRightArrow">
+            <a:avLst>
+              <a:gd name="adj1" fmla="val 1665"/>
+              <a:gd name="adj2" fmla="val 9629"/>
+              <a:gd name="adj3" fmla="val 15032"/>
+            </a:avLst>
+          </a:prstGeom>
+        </p:spPr>
+        <p:style>
+          <a:lnRef idx="2">
+            <a:schemeClr val="accent1">
+              <a:shade val="15000"/>
+            </a:schemeClr>
+          </a:lnRef>
+          <a:fillRef idx="1">
+            <a:schemeClr val="accent1"/>
+          </a:fillRef>
+          <a:effectRef idx="0">
+            <a:schemeClr val="accent1"/>
+          </a:effectRef>
+          <a:fontRef idx="minor">
+            <a:schemeClr val="lt1"/>
+          </a:fontRef>
+        </p:style>
+        <p:txBody>
+          <a:bodyPr rtlCol="1" anchor="ctr"/>
+          <a:lstStyle/>
+          <a:p>
+            <a:pPr algn="ctr"/>
+            <a:endParaRPr lang="he-IL">
+              <a:solidFill>
+                <a:schemeClr val="tx1"/>
+              </a:solidFill>
+            </a:endParaRPr>
+          </a:p>
+        </p:txBody>
+      </p:sp>
+      <p:pic>
+        <p:nvPicPr>
+          <p:cNvPr id="15" name="Picture 14">
+            <a:extLst>
+              <a:ext uri="{FF2B5EF4-FFF2-40B4-BE49-F238E27FC236}">
+                <a16:creationId xmlns:a16="http://schemas.microsoft.com/office/drawing/2014/main" id="{D93A2BC8-BFE6-E9D0-3D90-D81C496184AA}"/>
+              </a:ext>
+            </a:extLst>
+          </p:cNvPr>
+          <p:cNvPicPr>
+            <a:picLocks noChangeAspect="1"/>
+          </p:cNvPicPr>
+          <p:nvPr/>
+        </p:nvPicPr>
+        <p:blipFill>
+          <a:blip r:embed="rId3">
+            <a:extLst>
+              <a:ext uri="{28A0092B-C50C-407E-A947-70E740481C1C}">
+                <a14:useLocalDpi xmlns:a14="http://schemas.microsoft.com/office/drawing/2010/main" val="0"/>
+              </a:ext>
+            </a:extLst>
+          </a:blip>
+          <a:stretch>
+            <a:fillRect/>
+          </a:stretch>
+        </p:blipFill>
+        <p:spPr>
+          <a:xfrm>
+            <a:off x="8427313" y="3830579"/>
+            <a:ext cx="3608687" cy="3113999"/>
+          </a:xfrm>
+          <a:prstGeom prst="rect">
+            <a:avLst/>
+          </a:prstGeom>
+        </p:spPr>
+      </p:pic>
+    </p:spTree>
+    <p:extLst>
+      <p:ext uri="{BB962C8B-B14F-4D97-AF65-F5344CB8AC3E}">
+        <p14:creationId xmlns:p14="http://schemas.microsoft.com/office/powerpoint/2010/main" val="2833979806"/>
+      </p:ext>
+    </p:extLst>
+  </p:cSld>
+  <p:clrMapOvr>
+    <a:masterClrMapping/>
+  </p:clrMapOvr>
+</p:sld>
+</file>
+
+<file path=ppt/slides/slide4.xml><?xml version="1.0" encoding="utf-8"?>
+<p:sld xmlns:a="http://schemas.openxmlformats.org/drawingml/2006/main" xmlns:r="http://schemas.openxmlformats.org/officeDocument/2006/relationships" xmlns:p="http://schemas.openxmlformats.org/presentationml/2006/main">
+  <p:cSld>
+    <p:spTree>
+      <p:nvGrpSpPr>
+        <p:cNvPr id="1" name=""/>
+        <p:cNvGrpSpPr/>
+        <p:nvPr/>
+      </p:nvGrpSpPr>
+      <p:grpSpPr>
+        <a:xfrm>
+          <a:off x="0" y="0"/>
+          <a:ext cx="0" cy="0"/>
+          <a:chOff x="0" y="0"/>
+          <a:chExt cx="0" cy="0"/>
+        </a:xfrm>
+      </p:grpSpPr>
+      <p:sp>
+        <p:nvSpPr>
+          <p:cNvPr id="2" name="Title 1">
+            <a:extLst>
+              <a:ext uri="{FF2B5EF4-FFF2-40B4-BE49-F238E27FC236}">
+                <a16:creationId xmlns:a16="http://schemas.microsoft.com/office/drawing/2014/main" id="{2684DA81-633D-F68B-50DB-2A705811D451}"/>
+              </a:ext>
+            </a:extLst>
+          </p:cNvPr>
+          <p:cNvSpPr>
+            <a:spLocks noGrp="1"/>
+          </p:cNvSpPr>
+          <p:nvPr>
+            <p:ph type="title"/>
+          </p:nvPr>
+        </p:nvSpPr>
+        <p:spPr>
+          <a:xfrm>
+            <a:off x="381000" y="189000"/>
             <a:ext cx="10515600" cy="1325563"/>
           </a:xfrm>
         </p:spPr>
@@ -4675,192 +5510,6 @@
 </p:sld>
 </file>
 
-<file path=ppt/slides/slide3.xml><?xml version="1.0" encoding="utf-8"?>
-<p:sld xmlns:a="http://schemas.openxmlformats.org/drawingml/2006/main" xmlns:r="http://schemas.openxmlformats.org/officeDocument/2006/relationships" xmlns:p="http://schemas.openxmlformats.org/presentationml/2006/main">
-  <p:cSld>
-    <p:spTree>
-      <p:nvGrpSpPr>
-        <p:cNvPr id="1" name=""/>
-        <p:cNvGrpSpPr/>
-        <p:nvPr/>
-      </p:nvGrpSpPr>
-      <p:grpSpPr>
-        <a:xfrm>
-          <a:off x="0" y="0"/>
-          <a:ext cx="0" cy="0"/>
-          <a:chOff x="0" y="0"/>
-          <a:chExt cx="0" cy="0"/>
-        </a:xfrm>
-      </p:grpSpPr>
-      <p:sp>
-        <p:nvSpPr>
-          <p:cNvPr id="2" name="Title 1">
-            <a:extLst>
-              <a:ext uri="{FF2B5EF4-FFF2-40B4-BE49-F238E27FC236}">
-                <a16:creationId xmlns:a16="http://schemas.microsoft.com/office/drawing/2014/main" id="{79613971-1F6C-5EB3-FF31-0D694CE6D0DE}"/>
-              </a:ext>
-            </a:extLst>
-          </p:cNvPr>
-          <p:cNvSpPr>
-            <a:spLocks noGrp="1"/>
-          </p:cNvSpPr>
-          <p:nvPr>
-            <p:ph type="title"/>
-          </p:nvPr>
-        </p:nvSpPr>
-        <p:spPr/>
-        <p:txBody>
-          <a:bodyPr/>
-          <a:lstStyle/>
-          <a:p>
-            <a:r>
-              <a:rPr lang="en-US" dirty="0"/>
-              <a:t>First stage download a</a:t>
-            </a:r>
-            <a:endParaRPr lang="en-IL" dirty="0"/>
-          </a:p>
-        </p:txBody>
-      </p:sp>
-      <p:sp>
-        <p:nvSpPr>
-          <p:cNvPr id="3" name="Content Placeholder 2">
-            <a:extLst>
-              <a:ext uri="{FF2B5EF4-FFF2-40B4-BE49-F238E27FC236}">
-                <a16:creationId xmlns:a16="http://schemas.microsoft.com/office/drawing/2014/main" id="{27D38D13-1436-D0D0-544F-2CCB6EEFAF00}"/>
-              </a:ext>
-            </a:extLst>
-          </p:cNvPr>
-          <p:cNvSpPr>
-            <a:spLocks noGrp="1"/>
-          </p:cNvSpPr>
-          <p:nvPr>
-            <p:ph idx="1"/>
-          </p:nvPr>
-        </p:nvSpPr>
-        <p:spPr/>
-        <p:txBody>
-          <a:bodyPr/>
-          <a:lstStyle/>
-          <a:p>
-            <a:endParaRPr lang="en-IL"/>
-          </a:p>
-        </p:txBody>
-      </p:sp>
-    </p:spTree>
-    <p:extLst>
-      <p:ext uri="{BB962C8B-B14F-4D97-AF65-F5344CB8AC3E}">
-        <p14:creationId xmlns:p14="http://schemas.microsoft.com/office/powerpoint/2010/main" val="2833979806"/>
-      </p:ext>
-    </p:extLst>
-  </p:cSld>
-  <p:clrMapOvr>
-    <a:masterClrMapping/>
-  </p:clrMapOvr>
-</p:sld>
-</file>
-
-<file path=ppt/slides/slide4.xml><?xml version="1.0" encoding="utf-8"?>
-<p:sld xmlns:a="http://schemas.openxmlformats.org/drawingml/2006/main" xmlns:r="http://schemas.openxmlformats.org/officeDocument/2006/relationships" xmlns:p="http://schemas.openxmlformats.org/presentationml/2006/main">
-  <p:cSld>
-    <p:spTree>
-      <p:nvGrpSpPr>
-        <p:cNvPr id="1" name=""/>
-        <p:cNvGrpSpPr/>
-        <p:nvPr/>
-      </p:nvGrpSpPr>
-      <p:grpSpPr>
-        <a:xfrm>
-          <a:off x="0" y="0"/>
-          <a:ext cx="0" cy="0"/>
-          <a:chOff x="0" y="0"/>
-          <a:chExt cx="0" cy="0"/>
-        </a:xfrm>
-      </p:grpSpPr>
-      <p:sp>
-        <p:nvSpPr>
-          <p:cNvPr id="2" name="Title 1">
-            <a:extLst>
-              <a:ext uri="{FF2B5EF4-FFF2-40B4-BE49-F238E27FC236}">
-                <a16:creationId xmlns:a16="http://schemas.microsoft.com/office/drawing/2014/main" id="{3D7F13BC-C285-B689-FF33-42F010E61E19}"/>
-              </a:ext>
-            </a:extLst>
-          </p:cNvPr>
-          <p:cNvSpPr>
-            <a:spLocks noGrp="1"/>
-          </p:cNvSpPr>
-          <p:nvPr>
-            <p:ph type="title"/>
-          </p:nvPr>
-        </p:nvSpPr>
-        <p:spPr>
-          <a:xfrm>
-            <a:off x="291000" y="365125"/>
-            <a:ext cx="11835000" cy="1325563"/>
-          </a:xfrm>
-        </p:spPr>
-        <p:txBody>
-          <a:bodyPr>
-            <a:normAutofit/>
-          </a:bodyPr>
-          <a:lstStyle/>
-          <a:p>
-            <a:r>
-              <a:rPr lang="en-US" sz="4000" dirty="0"/>
-              <a:t>Generate the documents’ Semantic matrix</a:t>
-            </a:r>
-            <a:endParaRPr lang="en-IL" sz="4000" dirty="0"/>
-          </a:p>
-        </p:txBody>
-      </p:sp>
-      <p:pic>
-        <p:nvPicPr>
-          <p:cNvPr id="11" name="Picture 10">
-            <a:extLst>
-              <a:ext uri="{FF2B5EF4-FFF2-40B4-BE49-F238E27FC236}">
-                <a16:creationId xmlns:a16="http://schemas.microsoft.com/office/drawing/2014/main" id="{990EB87C-0CFA-1411-621E-4DEA9F98A16E}"/>
-              </a:ext>
-            </a:extLst>
-          </p:cNvPr>
-          <p:cNvPicPr>
-            <a:picLocks noChangeAspect="1"/>
-          </p:cNvPicPr>
-          <p:nvPr/>
-        </p:nvPicPr>
-        <p:blipFill>
-          <a:blip r:embed="rId2">
-            <a:extLst>
-              <a:ext uri="{28A0092B-C50C-407E-A947-70E740481C1C}">
-                <a14:useLocalDpi xmlns:a14="http://schemas.microsoft.com/office/drawing/2010/main" val="0"/>
-              </a:ext>
-            </a:extLst>
-          </a:blip>
-          <a:stretch>
-            <a:fillRect/>
-          </a:stretch>
-        </p:blipFill>
-        <p:spPr>
-          <a:xfrm>
-            <a:off x="1281000" y="1854000"/>
-            <a:ext cx="7785000" cy="4779160"/>
-          </a:xfrm>
-          <a:prstGeom prst="rect">
-            <a:avLst/>
-          </a:prstGeom>
-        </p:spPr>
-      </p:pic>
-    </p:spTree>
-    <p:extLst>
-      <p:ext uri="{BB962C8B-B14F-4D97-AF65-F5344CB8AC3E}">
-        <p14:creationId xmlns:p14="http://schemas.microsoft.com/office/powerpoint/2010/main" val="720069128"/>
-      </p:ext>
-    </p:extLst>
-  </p:cSld>
-  <p:clrMapOvr>
-    <a:masterClrMapping/>
-  </p:clrMapOvr>
-</p:sld>
-</file>
-
 <file path=ppt/slides/slide5.xml><?xml version="1.0" encoding="utf-8"?>
 <p:sld xmlns:a="http://schemas.openxmlformats.org/drawingml/2006/main" xmlns:r="http://schemas.openxmlformats.org/officeDocument/2006/relationships" xmlns:p="http://schemas.openxmlformats.org/presentationml/2006/main">
   <p:cSld>
@@ -4883,7 +5532,7 @@
           <p:cNvPr id="2" name="Title 1">
             <a:extLst>
               <a:ext uri="{FF2B5EF4-FFF2-40B4-BE49-F238E27FC236}">
-                <a16:creationId xmlns:a16="http://schemas.microsoft.com/office/drawing/2014/main" id="{E0D64089-DF5C-6359-8C67-4F1C87A9BF34}"/>
+                <a16:creationId xmlns:a16="http://schemas.microsoft.com/office/drawing/2014/main" id="{3D7F13BC-C285-B689-FF33-42F010E61E19}"/>
               </a:ext>
             </a:extLst>
           </p:cNvPr>
@@ -4894,46 +5543,32 @@
             <p:ph type="title"/>
           </p:nvPr>
         </p:nvSpPr>
-        <p:spPr/>
-        <p:txBody>
-          <a:bodyPr/>
+        <p:spPr>
+          <a:xfrm>
+            <a:off x="178500" y="0"/>
+            <a:ext cx="11835000" cy="1325563"/>
+          </a:xfrm>
+        </p:spPr>
+        <p:txBody>
+          <a:bodyPr>
+            <a:normAutofit/>
+          </a:bodyPr>
           <a:lstStyle/>
           <a:p>
-            <a:endParaRPr lang="en-IL"/>
-          </a:p>
-        </p:txBody>
-      </p:sp>
-      <p:sp>
-        <p:nvSpPr>
-          <p:cNvPr id="3" name="Content Placeholder 2">
-            <a:extLst>
-              <a:ext uri="{FF2B5EF4-FFF2-40B4-BE49-F238E27FC236}">
-                <a16:creationId xmlns:a16="http://schemas.microsoft.com/office/drawing/2014/main" id="{85F254F9-3842-4886-4AC8-5F2285CE48A6}"/>
-              </a:ext>
-            </a:extLst>
-          </p:cNvPr>
-          <p:cNvSpPr>
-            <a:spLocks noGrp="1"/>
-          </p:cNvSpPr>
-          <p:nvPr>
-            <p:ph idx="1"/>
-          </p:nvPr>
-        </p:nvSpPr>
-        <p:spPr/>
-        <p:txBody>
-          <a:bodyPr/>
-          <a:lstStyle/>
-          <a:p>
-            <a:endParaRPr lang="en-IL"/>
+            <a:r>
+              <a:rPr lang="en-US" sz="4000" dirty="0"/>
+              <a:t>Generate the documents’ Semantic matrix</a:t>
+            </a:r>
+            <a:endParaRPr lang="en-IL" sz="4000" dirty="0"/>
           </a:p>
         </p:txBody>
       </p:sp>
       <p:pic>
         <p:nvPicPr>
-          <p:cNvPr id="5" name="Picture 4">
-            <a:extLst>
-              <a:ext uri="{FF2B5EF4-FFF2-40B4-BE49-F238E27FC236}">
-                <a16:creationId xmlns:a16="http://schemas.microsoft.com/office/drawing/2014/main" id="{053B2453-1AFA-4FAA-1A1D-6D7E128BC97A}"/>
+          <p:cNvPr id="7" name="Picture 6">
+            <a:extLst>
+              <a:ext uri="{FF2B5EF4-FFF2-40B4-BE49-F238E27FC236}">
+                <a16:creationId xmlns:a16="http://schemas.microsoft.com/office/drawing/2014/main" id="{7A9CD730-7819-7256-5893-C2CC6B9ED364}"/>
               </a:ext>
             </a:extLst>
           </p:cNvPr>
@@ -4943,15 +5578,21 @@
           <p:nvPr/>
         </p:nvPicPr>
         <p:blipFill>
-          <a:blip r:embed="rId2"/>
+          <a:blip r:embed="rId2">
+            <a:extLst>
+              <a:ext uri="{28A0092B-C50C-407E-A947-70E740481C1C}">
+                <a14:useLocalDpi xmlns:a14="http://schemas.microsoft.com/office/drawing/2010/main" val="0"/>
+              </a:ext>
+            </a:extLst>
+          </a:blip>
           <a:stretch>
             <a:fillRect/>
           </a:stretch>
         </p:blipFill>
         <p:spPr>
           <a:xfrm>
-            <a:off x="4296000" y="2124000"/>
-            <a:ext cx="6573167" cy="3972479"/>
+            <a:off x="1101000" y="1269000"/>
+            <a:ext cx="9495000" cy="4747500"/>
           </a:xfrm>
           <a:prstGeom prst="rect">
             <a:avLst/>
@@ -4961,7 +5602,7 @@
     </p:spTree>
     <p:extLst>
       <p:ext uri="{BB962C8B-B14F-4D97-AF65-F5344CB8AC3E}">
-        <p14:creationId xmlns:p14="http://schemas.microsoft.com/office/powerpoint/2010/main" val="624567163"/>
+        <p14:creationId xmlns:p14="http://schemas.microsoft.com/office/powerpoint/2010/main" val="720069128"/>
       </p:ext>
     </p:extLst>
   </p:cSld>
@@ -4993,7 +5634,7 @@
           <p:cNvPr id="2" name="Title 1">
             <a:extLst>
               <a:ext uri="{FF2B5EF4-FFF2-40B4-BE49-F238E27FC236}">
-                <a16:creationId xmlns:a16="http://schemas.microsoft.com/office/drawing/2014/main" id="{59E06B02-D5AA-B5B7-75C3-CA45CA7E70C9}"/>
+                <a16:creationId xmlns:a16="http://schemas.microsoft.com/office/drawing/2014/main" id="{BA2EF1BD-FE72-D842-5D09-1E5E36FBB91F}"/>
               </a:ext>
             </a:extLst>
           </p:cNvPr>
@@ -5006,7 +5647,7 @@
         </p:nvSpPr>
         <p:spPr>
           <a:xfrm>
-            <a:off x="561000" y="18255"/>
+            <a:off x="471000" y="12865"/>
             <a:ext cx="10515600" cy="1325563"/>
           </a:xfrm>
         </p:spPr>
@@ -5016,48 +5657,18 @@
           <a:p>
             <a:r>
               <a:rPr lang="en-US" dirty="0"/>
-              <a:t>Training process</a:t>
-            </a:r>
-            <a:endParaRPr lang="en-IL" dirty="0"/>
-          </a:p>
-        </p:txBody>
-      </p:sp>
-      <p:sp>
-        <p:nvSpPr>
-          <p:cNvPr id="3" name="Content Placeholder 2">
-            <a:extLst>
-              <a:ext uri="{FF2B5EF4-FFF2-40B4-BE49-F238E27FC236}">
-                <a16:creationId xmlns:a16="http://schemas.microsoft.com/office/drawing/2014/main" id="{20DD5643-9849-68B5-8EFA-D29D33985AEA}"/>
-              </a:ext>
-            </a:extLst>
-          </p:cNvPr>
-          <p:cNvSpPr>
-            <a:spLocks noGrp="1"/>
-          </p:cNvSpPr>
-          <p:nvPr>
-            <p:ph idx="1"/>
-          </p:nvPr>
-        </p:nvSpPr>
-        <p:spPr>
-          <a:xfrm>
-            <a:off x="838200" y="1764000"/>
-            <a:ext cx="5257800" cy="4412963"/>
-          </a:xfrm>
-        </p:spPr>
-        <p:txBody>
-          <a:bodyPr/>
-          <a:lstStyle/>
-          <a:p>
-            <a:endParaRPr lang="en-IL" dirty="0"/>
+              <a:t>Searching process</a:t>
+            </a:r>
+            <a:endParaRPr lang="he-IL" dirty="0"/>
           </a:p>
         </p:txBody>
       </p:sp>
       <p:pic>
         <p:nvPicPr>
-          <p:cNvPr id="5" name="Picture 4">
-            <a:extLst>
-              <a:ext uri="{FF2B5EF4-FFF2-40B4-BE49-F238E27FC236}">
-                <a16:creationId xmlns:a16="http://schemas.microsoft.com/office/drawing/2014/main" id="{AC10F8A8-EC7E-75FC-7DAC-900EA2489BD7}"/>
+          <p:cNvPr id="13" name="Picture 12">
+            <a:extLst>
+              <a:ext uri="{FF2B5EF4-FFF2-40B4-BE49-F238E27FC236}">
+                <a16:creationId xmlns:a16="http://schemas.microsoft.com/office/drawing/2014/main" id="{03F453D5-CC12-D4C5-91A2-8FD0E89B6C40}"/>
               </a:ext>
             </a:extLst>
           </p:cNvPr>
@@ -5067,15 +5678,21 @@
           <p:nvPr/>
         </p:nvPicPr>
         <p:blipFill>
-          <a:blip r:embed="rId2"/>
+          <a:blip r:embed="rId2">
+            <a:extLst>
+              <a:ext uri="{28A0092B-C50C-407E-A947-70E740481C1C}">
+                <a14:useLocalDpi xmlns:a14="http://schemas.microsoft.com/office/drawing/2010/main" val="0"/>
+              </a:ext>
+            </a:extLst>
+          </a:blip>
           <a:stretch>
             <a:fillRect/>
           </a:stretch>
         </p:blipFill>
         <p:spPr>
           <a:xfrm>
-            <a:off x="5736001" y="1636372"/>
-            <a:ext cx="6456000" cy="4856503"/>
+            <a:off x="606000" y="2394000"/>
+            <a:ext cx="10847608" cy="3669225"/>
           </a:xfrm>
           <a:prstGeom prst="rect">
             <a:avLst/>
@@ -5085,7 +5702,7 @@
     </p:spTree>
     <p:extLst>
       <p:ext uri="{BB962C8B-B14F-4D97-AF65-F5344CB8AC3E}">
-        <p14:creationId xmlns:p14="http://schemas.microsoft.com/office/powerpoint/2010/main" val="1908824852"/>
+        <p14:creationId xmlns:p14="http://schemas.microsoft.com/office/powerpoint/2010/main" val="3802044812"/>
       </p:ext>
     </p:extLst>
   </p:cSld>

</xml_diff>